<commit_message>
Add English-named copy of payment path PPT for download
Co-Authored-By: Claude Opus 4.6 <noreply@anthropic.com>
</commit_message>
<xml_diff>
--- a/whistle-ai-payment-path.pptx
+++ b/whistle-ai-payment-path.pptx
@@ -3106,93 +3106,23 @@
       <p:grpSpPr/>
       <p:sp>
         <p:nvSpPr>
-          <p:cNvPr id="2" name="TextBox 1"/>
-          <p:cNvSpPr txBox="1"/>
-          <p:nvPr/>
-        </p:nvSpPr>
-        <p:spPr>
-          <a:xfrm>
-            <a:off x="914400" y="1371600"/>
-            <a:ext cx="10362895" cy="914400"/>
-          </a:xfrm>
-          <a:prstGeom prst="rect">
-            <a:avLst/>
-          </a:prstGeom>
-          <a:noFill/>
-        </p:spPr>
-        <p:txBody>
-          <a:bodyPr wrap="square">
-            <a:spAutoFit/>
-          </a:bodyPr>
-          <a:lstStyle/>
-          <a:p>
-            <a:pPr algn="ctr"/>
-            <a:r>
-              <a:rPr sz="3600" b="1">
-                <a:solidFill>
-                  <a:srgbClr val="000000"/>
-                </a:solidFill>
-              </a:rPr>
-              <a:t>Whistle AI 서비스 결제경로</a:t>
-            </a:r>
-          </a:p>
-        </p:txBody>
-      </p:sp>
-      <p:sp>
-        <p:nvSpPr>
-          <p:cNvPr id="3" name="TextBox 2"/>
-          <p:cNvSpPr txBox="1"/>
-          <p:nvPr/>
-        </p:nvSpPr>
-        <p:spPr>
-          <a:xfrm>
-            <a:off x="914400" y="2286000"/>
-            <a:ext cx="10362895" cy="457200"/>
-          </a:xfrm>
-          <a:prstGeom prst="rect">
-            <a:avLst/>
-          </a:prstGeom>
-          <a:noFill/>
-        </p:spPr>
-        <p:txBody>
-          <a:bodyPr wrap="square">
-            <a:spAutoFit/>
-          </a:bodyPr>
-          <a:lstStyle/>
-          <a:p>
-            <a:pPr algn="ctr"/>
-            <a:r>
-              <a:rPr sz="1800" b="0">
-                <a:solidFill>
-                  <a:srgbClr val="666666"/>
-                </a:solidFill>
-              </a:rPr>
-              <a:t>토스페이먼츠 카드사 심사용</a:t>
-            </a:r>
-          </a:p>
-        </p:txBody>
-      </p:sp>
-      <p:sp>
-        <p:nvSpPr>
-          <p:cNvPr id="4" name="Rounded Rectangle 3"/>
+          <p:cNvPr id="2" name="Rounded Rectangle 1"/>
           <p:cNvSpPr/>
           <p:nvPr/>
         </p:nvSpPr>
         <p:spPr>
           <a:xfrm>
-            <a:off x="2743200" y="3200400"/>
-            <a:ext cx="6705295" cy="3200400"/>
+            <a:off x="3200400" y="137160"/>
+            <a:ext cx="5790895" cy="548640"/>
           </a:xfrm>
           <a:prstGeom prst="roundRect">
             <a:avLst/>
           </a:prstGeom>
           <a:solidFill>
-            <a:srgbClr val="F8FAFF"/>
+            <a:srgbClr val="3B82F6"/>
           </a:solidFill>
           <a:ln>
-            <a:solidFill>
-              <a:srgbClr val="DEDEDE"/>
-            </a:solidFill>
+            <a:noFill/>
           </a:ln>
         </p:spPr>
         <p:style>
@@ -3210,6 +3140,83 @@
           </a:fontRef>
         </p:style>
         <p:txBody>
+          <a:bodyPr rtlCol="0" anchor="ctr" wrap="square"/>
+          <a:lstStyle/>
+          <a:p>
+            <a:pPr algn="ctr"/>
+            <a:r>
+              <a:rPr sz="2200" b="1">
+                <a:solidFill>
+                  <a:srgbClr val="FFFFFF"/>
+                </a:solidFill>
+              </a:rPr>
+              <a:t>① 가맹점 정보 기재</a:t>
+            </a:r>
+          </a:p>
+        </p:txBody>
+      </p:sp>
+      <p:pic>
+        <p:nvPicPr>
+          <p:cNvPr id="3" name="Picture 2" descr="01-hero.png"/>
+          <p:cNvPicPr>
+            <a:picLocks noChangeAspect="1"/>
+          </p:cNvPicPr>
+          <p:nvPr/>
+        </p:nvPicPr>
+        <p:blipFill>
+          <a:blip r:embed="rId2"/>
+          <a:stretch>
+            <a:fillRect/>
+          </a:stretch>
+        </p:blipFill>
+        <p:spPr>
+          <a:xfrm>
+            <a:off x="274320" y="1188720"/>
+            <a:ext cx="6217920" cy="4357402"/>
+          </a:xfrm>
+          <a:prstGeom prst="rect">
+            <a:avLst/>
+          </a:prstGeom>
+        </p:spPr>
+      </p:pic>
+      <p:sp>
+        <p:nvSpPr>
+          <p:cNvPr id="4" name="Rounded Rectangle 3"/>
+          <p:cNvSpPr/>
+          <p:nvPr/>
+        </p:nvSpPr>
+        <p:spPr>
+          <a:xfrm>
+            <a:off x="6766560" y="1188720"/>
+            <a:ext cx="5120640" cy="5303520"/>
+          </a:xfrm>
+          <a:prstGeom prst="roundRect">
+            <a:avLst/>
+          </a:prstGeom>
+          <a:solidFill>
+            <a:srgbClr val="F8FAFF"/>
+          </a:solidFill>
+          <a:ln>
+            <a:solidFill>
+              <a:srgbClr val="DEDEDE"/>
+            </a:solidFill>
+          </a:ln>
+        </p:spPr>
+        <p:style>
+          <a:lnRef idx="1">
+            <a:schemeClr val="accent1"/>
+          </a:lnRef>
+          <a:fillRef idx="3">
+            <a:schemeClr val="accent1"/>
+          </a:fillRef>
+          <a:effectRef idx="2">
+            <a:schemeClr val="accent1"/>
+          </a:effectRef>
+          <a:fontRef idx="minor">
+            <a:schemeClr val="lt1"/>
+          </a:fontRef>
+        </p:style>
+        <p:txBody>
           <a:bodyPr rtlCol="0" anchor="ctr"/>
           <a:lstStyle/>
           <a:p>
@@ -3225,8 +3232,8 @@
         </p:nvSpPr>
         <p:spPr>
           <a:xfrm>
-            <a:off x="3200400" y="3383280"/>
-            <a:ext cx="1828800" cy="365760"/>
+            <a:off x="7040880" y="1371600"/>
+            <a:ext cx="1645920" cy="320040"/>
           </a:xfrm>
           <a:prstGeom prst="rect">
             <a:avLst/>
@@ -3241,12 +3248,12 @@
           <a:p>
             <a:pPr algn="l"/>
             <a:r>
-              <a:rPr sz="1600" b="1">
+              <a:rPr sz="1300" b="1">
                 <a:solidFill>
                   <a:srgbClr val="3B82F6"/>
                 </a:solidFill>
               </a:rPr>
-              <a:t>(1) 상호명</a:t>
+              <a:t>상호명</a:t>
             </a:r>
           </a:p>
         </p:txBody>
@@ -3259,8 +3266,8 @@
         </p:nvSpPr>
         <p:spPr>
           <a:xfrm>
-            <a:off x="5303520" y="3383280"/>
-            <a:ext cx="4114800" cy="365760"/>
+            <a:off x="8686800" y="1371600"/>
+            <a:ext cx="3017520" cy="502920"/>
           </a:xfrm>
           <a:prstGeom prst="rect">
             <a:avLst/>
@@ -3275,12 +3282,12 @@
           <a:p>
             <a:pPr algn="l"/>
             <a:r>
-              <a:rPr sz="1600" b="0">
+              <a:rPr sz="1300" b="0">
                 <a:solidFill>
                   <a:srgbClr val="000000"/>
                 </a:solidFill>
               </a:rPr>
-              <a:t>:  (주)모티브이노베이션</a:t>
+              <a:t>(주)모티브이노베이션</a:t>
             </a:r>
           </a:p>
         </p:txBody>
@@ -3293,8 +3300,8 @@
         </p:nvSpPr>
         <p:spPr>
           <a:xfrm>
-            <a:off x="3200400" y="3840480"/>
-            <a:ext cx="1828800" cy="365760"/>
+            <a:off x="7040880" y="1920240"/>
+            <a:ext cx="1645920" cy="320040"/>
           </a:xfrm>
           <a:prstGeom prst="rect">
             <a:avLst/>
@@ -3309,12 +3316,12 @@
           <a:p>
             <a:pPr algn="l"/>
             <a:r>
-              <a:rPr sz="1600" b="1">
+              <a:rPr sz="1300" b="1">
                 <a:solidFill>
                   <a:srgbClr val="3B82F6"/>
                 </a:solidFill>
               </a:rPr>
-              <a:t>(2) 사업자번호</a:t>
+              <a:t>사업자번호</a:t>
             </a:r>
           </a:p>
         </p:txBody>
@@ -3327,8 +3334,8 @@
         </p:nvSpPr>
         <p:spPr>
           <a:xfrm>
-            <a:off x="5303520" y="3840480"/>
-            <a:ext cx="4114800" cy="365760"/>
+            <a:off x="8686800" y="1920240"/>
+            <a:ext cx="3017520" cy="502920"/>
           </a:xfrm>
           <a:prstGeom prst="rect">
             <a:avLst/>
@@ -3343,12 +3350,12 @@
           <a:p>
             <a:pPr algn="l"/>
             <a:r>
-              <a:rPr sz="1600" b="0">
+              <a:rPr sz="1300" b="0">
                 <a:solidFill>
                   <a:srgbClr val="000000"/>
                 </a:solidFill>
               </a:rPr>
-              <a:t>:  155-88-02209</a:t>
+              <a:t>155-88-02209</a:t>
             </a:r>
           </a:p>
         </p:txBody>
@@ -3361,8 +3368,8 @@
         </p:nvSpPr>
         <p:spPr>
           <a:xfrm>
-            <a:off x="3200400" y="4297680"/>
-            <a:ext cx="1828800" cy="365760"/>
+            <a:off x="7040880" y="2468880"/>
+            <a:ext cx="1645920" cy="320040"/>
           </a:xfrm>
           <a:prstGeom prst="rect">
             <a:avLst/>
@@ -3377,12 +3384,12 @@
           <a:p>
             <a:pPr algn="l"/>
             <a:r>
-              <a:rPr sz="1600" b="1">
+              <a:rPr sz="1300" b="1">
                 <a:solidFill>
                   <a:srgbClr val="3B82F6"/>
                 </a:solidFill>
               </a:rPr>
-              <a:t>(3) 서비스 URL</a:t>
+              <a:t>대표자명</a:t>
             </a:r>
           </a:p>
         </p:txBody>
@@ -3395,8 +3402,8 @@
         </p:nvSpPr>
         <p:spPr>
           <a:xfrm>
-            <a:off x="5303520" y="4297680"/>
-            <a:ext cx="4114800" cy="365760"/>
+            <a:off x="8686800" y="2468880"/>
+            <a:ext cx="3017520" cy="502920"/>
           </a:xfrm>
           <a:prstGeom prst="rect">
             <a:avLst/>
@@ -3411,12 +3418,12 @@
           <a:p>
             <a:pPr algn="l"/>
             <a:r>
-              <a:rPr sz="1600" b="0">
+              <a:rPr sz="1300" b="0">
                 <a:solidFill>
                   <a:srgbClr val="000000"/>
                 </a:solidFill>
               </a:rPr>
-              <a:t>:  https://motiveinno-jpg.github.io/motive-team/whistle-landing.html</a:t>
+              <a:t>채희웅</a:t>
             </a:r>
           </a:p>
         </p:txBody>
@@ -3429,8 +3436,8 @@
         </p:nvSpPr>
         <p:spPr>
           <a:xfrm>
-            <a:off x="3200400" y="4754880"/>
-            <a:ext cx="1828800" cy="365760"/>
+            <a:off x="7040880" y="3017520"/>
+            <a:ext cx="1645920" cy="320040"/>
           </a:xfrm>
           <a:prstGeom prst="rect">
             <a:avLst/>
@@ -3445,12 +3452,12 @@
           <a:p>
             <a:pPr algn="l"/>
             <a:r>
-              <a:rPr sz="1600" b="1">
+              <a:rPr sz="1300" b="1">
                 <a:solidFill>
                   <a:srgbClr val="3B82F6"/>
                 </a:solidFill>
               </a:rPr>
-              <a:t>(4) 앱 URL</a:t>
+              <a:t>서비스 URL</a:t>
             </a:r>
           </a:p>
         </p:txBody>
@@ -3463,8 +3470,8 @@
         </p:nvSpPr>
         <p:spPr>
           <a:xfrm>
-            <a:off x="5303520" y="4754880"/>
-            <a:ext cx="4114800" cy="365760"/>
+            <a:off x="8686800" y="3017520"/>
+            <a:ext cx="3017520" cy="502920"/>
           </a:xfrm>
           <a:prstGeom prst="rect">
             <a:avLst/>
@@ -3479,12 +3486,12 @@
           <a:p>
             <a:pPr algn="l"/>
             <a:r>
-              <a:rPr sz="1600" b="0">
+              <a:rPr sz="1300" b="0">
                 <a:solidFill>
                   <a:srgbClr val="000000"/>
                 </a:solidFill>
               </a:rPr>
-              <a:t>:  https://www.owner-view.com</a:t>
+              <a:t>https://whistle-ai.com</a:t>
             </a:r>
           </a:p>
         </p:txBody>
@@ -3497,8 +3504,8 @@
         </p:nvSpPr>
         <p:spPr>
           <a:xfrm>
-            <a:off x="3200400" y="5212080"/>
-            <a:ext cx="1828800" cy="365760"/>
+            <a:off x="7040880" y="3566160"/>
+            <a:ext cx="1645920" cy="320040"/>
           </a:xfrm>
           <a:prstGeom prst="rect">
             <a:avLst/>
@@ -3513,12 +3520,12 @@
           <a:p>
             <a:pPr algn="l"/>
             <a:r>
-              <a:rPr sz="1600" b="1">
+              <a:rPr sz="1300" b="1">
                 <a:solidFill>
                   <a:srgbClr val="3B82F6"/>
                 </a:solidFill>
               </a:rPr>
-              <a:t>(5) Test ID</a:t>
+              <a:t>랜딩페이지</a:t>
             </a:r>
           </a:p>
         </p:txBody>
@@ -3531,8 +3538,8 @@
         </p:nvSpPr>
         <p:spPr>
           <a:xfrm>
-            <a:off x="5303520" y="5212080"/>
-            <a:ext cx="4114800" cy="365760"/>
+            <a:off x="8686800" y="3566160"/>
+            <a:ext cx="3017520" cy="502920"/>
           </a:xfrm>
           <a:prstGeom prst="rect">
             <a:avLst/>
@@ -3547,12 +3554,13 @@
           <a:p>
             <a:pPr algn="l"/>
             <a:r>
-              <a:rPr sz="1600" b="0">
+              <a:rPr sz="1300" b="0">
                 <a:solidFill>
                   <a:srgbClr val="000000"/>
                 </a:solidFill>
               </a:rPr>
-              <a:t>:  test@motiveinnovation.co.kr</a:t>
+              <a:t>motiveinno-jpg.github.io/
+  motive-team/whistle-landing.html</a:t>
             </a:r>
           </a:p>
         </p:txBody>
@@ -3565,8 +3573,8 @@
         </p:nvSpPr>
         <p:spPr>
           <a:xfrm>
-            <a:off x="3200400" y="5669280"/>
-            <a:ext cx="1828800" cy="365760"/>
+            <a:off x="7040880" y="4114800"/>
+            <a:ext cx="1645920" cy="320040"/>
           </a:xfrm>
           <a:prstGeom prst="rect">
             <a:avLst/>
@@ -3581,12 +3589,12 @@
           <a:p>
             <a:pPr algn="l"/>
             <a:r>
-              <a:rPr sz="1600" b="1">
+              <a:rPr sz="1300" b="1">
                 <a:solidFill>
                   <a:srgbClr val="3B82F6"/>
                 </a:solidFill>
               </a:rPr>
-              <a:t>(6) Test PW</a:t>
+              <a:t>앱(모바일웹)</a:t>
             </a:r>
           </a:p>
         </p:txBody>
@@ -3599,8 +3607,8 @@
         </p:nvSpPr>
         <p:spPr>
           <a:xfrm>
-            <a:off x="5303520" y="5669280"/>
-            <a:ext cx="4114800" cy="365760"/>
+            <a:off x="8686800" y="4114800"/>
+            <a:ext cx="3017520" cy="502920"/>
           </a:xfrm>
           <a:prstGeom prst="rect">
             <a:avLst/>
@@ -3615,12 +3623,148 @@
           <a:p>
             <a:pPr algn="l"/>
             <a:r>
-              <a:rPr sz="1600" b="0">
+              <a:rPr sz="1300" b="0">
                 <a:solidFill>
                   <a:srgbClr val="000000"/>
                 </a:solidFill>
               </a:rPr>
-              <a:t>:  Test1234!@</a:t>
+              <a:t>https://www.owner-view.com</a:t>
+            </a:r>
+          </a:p>
+        </p:txBody>
+      </p:sp>
+      <p:sp>
+        <p:nvSpPr>
+          <p:cNvPr id="17" name="TextBox 16"/>
+          <p:cNvSpPr txBox="1"/>
+          <p:nvPr/>
+        </p:nvSpPr>
+        <p:spPr>
+          <a:xfrm>
+            <a:off x="7040880" y="4663440"/>
+            <a:ext cx="1645920" cy="320040"/>
+          </a:xfrm>
+          <a:prstGeom prst="rect">
+            <a:avLst/>
+          </a:prstGeom>
+          <a:noFill/>
+        </p:spPr>
+        <p:txBody>
+          <a:bodyPr wrap="square">
+            <a:spAutoFit/>
+          </a:bodyPr>
+          <a:lstStyle/>
+          <a:p>
+            <a:pPr algn="l"/>
+            <a:r>
+              <a:rPr sz="1300" b="1">
+                <a:solidFill>
+                  <a:srgbClr val="3B82F6"/>
+                </a:solidFill>
+              </a:rPr>
+              <a:t>테스트 ID</a:t>
+            </a:r>
+          </a:p>
+        </p:txBody>
+      </p:sp>
+      <p:sp>
+        <p:nvSpPr>
+          <p:cNvPr id="18" name="TextBox 17"/>
+          <p:cNvSpPr txBox="1"/>
+          <p:nvPr/>
+        </p:nvSpPr>
+        <p:spPr>
+          <a:xfrm>
+            <a:off x="8686800" y="4663440"/>
+            <a:ext cx="3017520" cy="502920"/>
+          </a:xfrm>
+          <a:prstGeom prst="rect">
+            <a:avLst/>
+          </a:prstGeom>
+          <a:noFill/>
+        </p:spPr>
+        <p:txBody>
+          <a:bodyPr wrap="square">
+            <a:spAutoFit/>
+          </a:bodyPr>
+          <a:lstStyle/>
+          <a:p>
+            <a:pPr algn="l"/>
+            <a:r>
+              <a:rPr sz="1300" b="0">
+                <a:solidFill>
+                  <a:srgbClr val="000000"/>
+                </a:solidFill>
+              </a:rPr>
+              <a:t>test@motiveinnovation.co.kr</a:t>
+            </a:r>
+          </a:p>
+        </p:txBody>
+      </p:sp>
+      <p:sp>
+        <p:nvSpPr>
+          <p:cNvPr id="19" name="TextBox 18"/>
+          <p:cNvSpPr txBox="1"/>
+          <p:nvPr/>
+        </p:nvSpPr>
+        <p:spPr>
+          <a:xfrm>
+            <a:off x="7040880" y="5212079"/>
+            <a:ext cx="1645920" cy="320040"/>
+          </a:xfrm>
+          <a:prstGeom prst="rect">
+            <a:avLst/>
+          </a:prstGeom>
+          <a:noFill/>
+        </p:spPr>
+        <p:txBody>
+          <a:bodyPr wrap="square">
+            <a:spAutoFit/>
+          </a:bodyPr>
+          <a:lstStyle/>
+          <a:p>
+            <a:pPr algn="l"/>
+            <a:r>
+              <a:rPr sz="1300" b="1">
+                <a:solidFill>
+                  <a:srgbClr val="3B82F6"/>
+                </a:solidFill>
+              </a:rPr>
+              <a:t>테스트 PW</a:t>
+            </a:r>
+          </a:p>
+        </p:txBody>
+      </p:sp>
+      <p:sp>
+        <p:nvSpPr>
+          <p:cNvPr id="20" name="TextBox 19"/>
+          <p:cNvSpPr txBox="1"/>
+          <p:nvPr/>
+        </p:nvSpPr>
+        <p:spPr>
+          <a:xfrm>
+            <a:off x="8686800" y="5212079"/>
+            <a:ext cx="3017520" cy="502920"/>
+          </a:xfrm>
+          <a:prstGeom prst="rect">
+            <a:avLst/>
+          </a:prstGeom>
+          <a:noFill/>
+        </p:spPr>
+        <p:txBody>
+          <a:bodyPr wrap="square">
+            <a:spAutoFit/>
+          </a:bodyPr>
+          <a:lstStyle/>
+          <a:p>
+            <a:pPr algn="l"/>
+            <a:r>
+              <a:rPr sz="1300" b="0">
+                <a:solidFill>
+                  <a:srgbClr val="000000"/>
+                </a:solidFill>
+              </a:rPr>
+              <a:t>Test1234!@</a:t>
             </a:r>
           </a:p>
         </p:txBody>
@@ -3659,8 +3803,8 @@
         </p:nvSpPr>
         <p:spPr>
           <a:xfrm>
-            <a:off x="3200400" y="182880"/>
-            <a:ext cx="5790895" cy="594360"/>
+            <a:off x="3200400" y="137160"/>
+            <a:ext cx="5790895" cy="548640"/>
           </a:xfrm>
           <a:prstGeom prst="roundRect">
             <a:avLst/>
@@ -3692,7 +3836,7 @@
           <a:p>
             <a:pPr algn="ctr"/>
             <a:r>
-              <a:rPr sz="2400" b="1">
+              <a:rPr sz="2200" b="1">
                 <a:solidFill>
                   <a:srgbClr val="FFFFFF"/>
                 </a:solidFill>
@@ -3710,8 +3854,8 @@
         </p:nvSpPr>
         <p:spPr>
           <a:xfrm>
-            <a:off x="914400" y="914400"/>
-            <a:ext cx="10362895" cy="457200"/>
+            <a:off x="457200" y="777240"/>
+            <a:ext cx="11277295" cy="365760"/>
           </a:xfrm>
           <a:prstGeom prst="rect">
             <a:avLst/>
@@ -3726,76 +3870,19 @@
           <a:p>
             <a:pPr algn="ctr"/>
             <a:r>
-              <a:rPr sz="1400">
+              <a:rPr sz="1200">
                 <a:solidFill>
                   <a:srgbClr val="666666"/>
                 </a:solidFill>
               </a:rPr>
-              <a:t>필수 구성 항목: (1)상호명 / (2)대표자명 / (3)사업자등록번호 / (4)통신판매업신고번호 / (5)사업장주소 / (6)상점 전화번호</a:t>
-            </a:r>
-          </a:p>
-        </p:txBody>
-      </p:sp>
-      <p:sp>
-        <p:nvSpPr>
-          <p:cNvPr id="4" name="Rounded Rectangle 3"/>
-          <p:cNvSpPr/>
-          <p:nvPr/>
-        </p:nvSpPr>
-        <p:spPr>
-          <a:xfrm>
-            <a:off x="1371600" y="1463040"/>
-            <a:ext cx="9448495" cy="320040"/>
-          </a:xfrm>
-          <a:prstGeom prst="roundRect">
-            <a:avLst/>
-          </a:prstGeom>
-          <a:solidFill>
-            <a:srgbClr val="F1F3F5"/>
-          </a:solidFill>
-          <a:ln w="6350">
-            <a:solidFill>
-              <a:srgbClr val="DEDEDE"/>
-            </a:solidFill>
-          </a:ln>
-        </p:spPr>
-        <p:style>
-          <a:lnRef idx="1">
-            <a:schemeClr val="accent1"/>
-          </a:lnRef>
-          <a:fillRef idx="3">
-            <a:schemeClr val="accent1"/>
-          </a:fillRef>
-          <a:effectRef idx="2">
-            <a:schemeClr val="accent1"/>
-          </a:effectRef>
-          <a:fontRef idx="minor">
-            <a:schemeClr val="lt1"/>
-          </a:fontRef>
-        </p:style>
-        <p:txBody>
-          <a:bodyPr rtlCol="0" anchor="ctr" wrap="none"/>
-          <a:lstStyle/>
-          <a:p>
-            <a:pPr algn="l"/>
-            <a:r>
-              <a:rPr sz="1000"/>
-              <a:t>  🔒 </a:t>
-            </a:r>
-            <a:r>
-              <a:rPr sz="1000">
-                <a:solidFill>
-                  <a:srgbClr val="333333"/>
-                </a:solidFill>
-              </a:rPr>
-              <a:t>motiveinno-jpg.github.io/motive-team/whistle-landing.html</a:t>
+              <a:t>상호명 / 대표자명 / 사업자등록번호 / 통신판매업신고번호 / 사업장주소 / 전화번호</a:t>
             </a:r>
           </a:p>
         </p:txBody>
       </p:sp>
       <p:pic>
         <p:nvPicPr>
-          <p:cNvPr id="5" name="Picture 4" descr="02-footer.png"/>
+          <p:cNvPr id="4" name="Picture 3" descr="02-footer.png"/>
           <p:cNvPicPr>
             <a:picLocks noChangeAspect="1"/>
           </p:cNvPicPr>
@@ -3809,8 +3896,8 @@
         </p:blipFill>
         <p:spPr>
           <a:xfrm>
-            <a:off x="1371600" y="1783080"/>
-            <a:ext cx="9448495" cy="5905309"/>
+            <a:off x="1097280" y="1234440"/>
+            <a:ext cx="9966960" cy="6984659"/>
           </a:xfrm>
           <a:prstGeom prst="rect">
             <a:avLst/>
@@ -3851,8 +3938,8 @@
         </p:nvSpPr>
         <p:spPr>
           <a:xfrm>
-            <a:off x="3200400" y="182880"/>
-            <a:ext cx="5790895" cy="594360"/>
+            <a:off x="3200400" y="137160"/>
+            <a:ext cx="5790895" cy="548640"/>
           </a:xfrm>
           <a:prstGeom prst="roundRect">
             <a:avLst/>
@@ -3884,12 +3971,12 @@
           <a:p>
             <a:pPr algn="ctr"/>
             <a:r>
-              <a:rPr sz="2400" b="1">
+              <a:rPr sz="2200" b="1">
                 <a:solidFill>
                   <a:srgbClr val="FFFFFF"/>
                 </a:solidFill>
               </a:rPr>
-              <a:t>③ 환불규정 캡처 (무형상품)</a:t>
+              <a:t>③ 환불규정 캡처</a:t>
             </a:r>
           </a:p>
         </p:txBody>
@@ -3902,8 +3989,8 @@
         </p:nvSpPr>
         <p:spPr>
           <a:xfrm>
-            <a:off x="914400" y="914400"/>
-            <a:ext cx="10362895" cy="457200"/>
+            <a:off x="457200" y="777240"/>
+            <a:ext cx="11277295" cy="365760"/>
           </a:xfrm>
           <a:prstGeom prst="rect">
             <a:avLst/>
@@ -3918,76 +4005,19 @@
           <a:p>
             <a:pPr algn="ctr"/>
             <a:r>
-              <a:rPr sz="1400">
+              <a:rPr sz="1200">
                 <a:solidFill>
                   <a:srgbClr val="666666"/>
                 </a:solidFill>
               </a:rPr>
-              <a:t>환불 규정을 캡처해요. 전자상거래법에 따른 청약철회 및 환불 정책</a:t>
-            </a:r>
-          </a:p>
-        </p:txBody>
-      </p:sp>
-      <p:sp>
-        <p:nvSpPr>
-          <p:cNvPr id="4" name="Rounded Rectangle 3"/>
-          <p:cNvSpPr/>
-          <p:nvPr/>
-        </p:nvSpPr>
-        <p:spPr>
-          <a:xfrm>
-            <a:off x="1371600" y="1463040"/>
-            <a:ext cx="9448495" cy="320040"/>
-          </a:xfrm>
-          <a:prstGeom prst="roundRect">
-            <a:avLst/>
-          </a:prstGeom>
-          <a:solidFill>
-            <a:srgbClr val="F1F3F5"/>
-          </a:solidFill>
-          <a:ln w="6350">
-            <a:solidFill>
-              <a:srgbClr val="DEDEDE"/>
-            </a:solidFill>
-          </a:ln>
-        </p:spPr>
-        <p:style>
-          <a:lnRef idx="1">
-            <a:schemeClr val="accent1"/>
-          </a:lnRef>
-          <a:fillRef idx="3">
-            <a:schemeClr val="accent1"/>
-          </a:fillRef>
-          <a:effectRef idx="2">
-            <a:schemeClr val="accent1"/>
-          </a:effectRef>
-          <a:fontRef idx="minor">
-            <a:schemeClr val="lt1"/>
-          </a:fontRef>
-        </p:style>
-        <p:txBody>
-          <a:bodyPr rtlCol="0" anchor="ctr" wrap="none"/>
-          <a:lstStyle/>
-          <a:p>
-            <a:pPr algn="l"/>
-            <a:r>
-              <a:rPr sz="1000"/>
-              <a:t>  🔒 </a:t>
-            </a:r>
-            <a:r>
-              <a:rPr sz="1000">
-                <a:solidFill>
-                  <a:srgbClr val="333333"/>
-                </a:solidFill>
-              </a:rPr>
-              <a:t>motiveinno-jpg.github.io/motive-team/refund.html</a:t>
+              <a:t>전자상거래법에 따른 청약철회 및 환불 정책 (무형상품 — SaaS 구독 서비스)</a:t>
             </a:r>
           </a:p>
         </p:txBody>
       </p:sp>
       <p:pic>
         <p:nvPicPr>
-          <p:cNvPr id="5" name="Picture 4" descr="03-refund.png"/>
+          <p:cNvPr id="4" name="Picture 3" descr="03-refund.png"/>
           <p:cNvPicPr>
             <a:picLocks noChangeAspect="1"/>
           </p:cNvPicPr>
@@ -4001,8 +4031,8 @@
         </p:blipFill>
         <p:spPr>
           <a:xfrm>
-            <a:off x="1371600" y="1783080"/>
-            <a:ext cx="9448495" cy="5905309"/>
+            <a:off x="1097280" y="1234440"/>
+            <a:ext cx="9966960" cy="6984659"/>
           </a:xfrm>
           <a:prstGeom prst="rect">
             <a:avLst/>
@@ -4043,8 +4073,8 @@
         </p:nvSpPr>
         <p:spPr>
           <a:xfrm>
-            <a:off x="3200400" y="182880"/>
-            <a:ext cx="5790895" cy="594360"/>
+            <a:off x="3200400" y="137160"/>
+            <a:ext cx="5790895" cy="548640"/>
           </a:xfrm>
           <a:prstGeom prst="roundRect">
             <a:avLst/>
@@ -4076,12 +4106,12 @@
           <a:p>
             <a:pPr algn="ctr"/>
             <a:r>
-              <a:rPr sz="2400" b="1">
+              <a:rPr sz="2200" b="1">
                 <a:solidFill>
                   <a:srgbClr val="FFFFFF"/>
                 </a:solidFill>
               </a:rPr>
-              <a:t>④ 로그인 / 회원가입 캡처 (웹 — Whistle AI)</a:t>
+              <a:t>④ 로그인 / 회원가입 캡처 (웹 — Whistle AI 랜딩페이지)</a:t>
             </a:r>
           </a:p>
         </p:txBody>
@@ -4094,8 +4124,8 @@
         </p:nvSpPr>
         <p:spPr>
           <a:xfrm>
-            <a:off x="914400" y="914400"/>
-            <a:ext cx="10362895" cy="457200"/>
+            <a:off x="457200" y="777240"/>
+            <a:ext cx="11277295" cy="365760"/>
           </a:xfrm>
           <a:prstGeom prst="rect">
             <a:avLst/>
@@ -4110,69 +4140,46 @@
           <a:p>
             <a:pPr algn="ctr"/>
             <a:r>
-              <a:rPr sz="1400">
+              <a:rPr sz="1200">
                 <a:solidFill>
                   <a:srgbClr val="666666"/>
                 </a:solidFill>
               </a:rPr>
-              <a:t>로그인 혹은 회원가입 경로를 캡처해요.</a:t>
-            </a:r>
-          </a:p>
-        </p:txBody>
-      </p:sp>
-      <p:sp>
-        <p:nvSpPr>
-          <p:cNvPr id="4" name="Rounded Rectangle 3"/>
-          <p:cNvSpPr/>
+              <a:t>이메일 + 비밀번호 로그인 / 회원가입</a:t>
+            </a:r>
+          </a:p>
+        </p:txBody>
+      </p:sp>
+      <p:sp>
+        <p:nvSpPr>
+          <p:cNvPr id="4" name="TextBox 3"/>
+          <p:cNvSpPr txBox="1"/>
           <p:nvPr/>
         </p:nvSpPr>
         <p:spPr>
           <a:xfrm>
-            <a:off x="457200" y="1463040"/>
-            <a:ext cx="5029200" cy="320040"/>
-          </a:xfrm>
-          <a:prstGeom prst="roundRect">
-            <a:avLst/>
-          </a:prstGeom>
-          <a:solidFill>
-            <a:srgbClr val="F1F3F5"/>
-          </a:solidFill>
-          <a:ln w="6350">
-            <a:solidFill>
-              <a:srgbClr val="DEDEDE"/>
-            </a:solidFill>
-          </a:ln>
-        </p:spPr>
-        <p:style>
-          <a:lnRef idx="1">
-            <a:schemeClr val="accent1"/>
-          </a:lnRef>
-          <a:fillRef idx="3">
-            <a:schemeClr val="accent1"/>
-          </a:fillRef>
-          <a:effectRef idx="2">
-            <a:schemeClr val="accent1"/>
-          </a:effectRef>
-          <a:fontRef idx="minor">
-            <a:schemeClr val="lt1"/>
-          </a:fontRef>
-        </p:style>
-        <p:txBody>
-          <a:bodyPr rtlCol="0" anchor="ctr" wrap="none"/>
+            <a:off x="457200" y="1097280"/>
+            <a:ext cx="5486400" cy="274320"/>
+          </a:xfrm>
+          <a:prstGeom prst="rect">
+            <a:avLst/>
+          </a:prstGeom>
+          <a:noFill/>
+        </p:spPr>
+        <p:txBody>
+          <a:bodyPr wrap="square">
+            <a:spAutoFit/>
+          </a:bodyPr>
           <a:lstStyle/>
           <a:p>
             <a:pPr algn="l"/>
             <a:r>
-              <a:rPr sz="1000"/>
-              <a:t>  🔒 </a:t>
-            </a:r>
-            <a:r>
-              <a:rPr sz="1000">
-                <a:solidFill>
-                  <a:srgbClr val="333333"/>
+              <a:rPr sz="1300" b="1">
+                <a:solidFill>
+                  <a:srgbClr val="1E40AF"/>
                 </a:solidFill>
               </a:rPr>
-              <a:t>motiveinno-jpg.github.io/motive-team/whistle-landing.html</a:t>
+              <a:t>▶ 로그인 모달</a:t>
             </a:r>
           </a:p>
         </p:txBody>
@@ -4193,8 +4200,8 @@
         </p:blipFill>
         <p:spPr>
           <a:xfrm>
-            <a:off x="457200" y="1783080"/>
-            <a:ext cx="5029200" cy="3143250"/>
+            <a:off x="457200" y="1371600"/>
+            <a:ext cx="5577840" cy="3908846"/>
           </a:xfrm>
           <a:prstGeom prst="rect">
             <a:avLst/>
@@ -4209,8 +4216,8 @@
         </p:nvSpPr>
         <p:spPr>
           <a:xfrm>
-            <a:off x="457200" y="1188720"/>
-            <a:ext cx="5029200" cy="274320"/>
+            <a:off x="6400800" y="1097280"/>
+            <a:ext cx="5486400" cy="274320"/>
           </a:xfrm>
           <a:prstGeom prst="rect">
             <a:avLst/>
@@ -4225,12 +4232,12 @@
           <a:p>
             <a:pPr algn="l"/>
             <a:r>
-              <a:rPr sz="1200" b="1">
+              <a:rPr sz="1300" b="1">
                 <a:solidFill>
                   <a:srgbClr val="1E40AF"/>
                 </a:solidFill>
               </a:rPr>
-              <a:t>▶ 로그인 모달</a:t>
+              <a:t>▶ 회원가입 안내</a:t>
             </a:r>
           </a:p>
         </p:txBody>
@@ -4243,8 +4250,8 @@
         </p:nvSpPr>
         <p:spPr>
           <a:xfrm>
-            <a:off x="5943600" y="1188720"/>
-            <a:ext cx="5486400" cy="274320"/>
+            <a:off x="6400800" y="1463040"/>
+            <a:ext cx="5029200" cy="3657600"/>
           </a:xfrm>
           <a:prstGeom prst="rect">
             <a:avLst/>
@@ -4259,48 +4266,20 @@
           <a:p>
             <a:pPr algn="l"/>
             <a:r>
-              <a:rPr sz="1200" b="1">
-                <a:solidFill>
-                  <a:srgbClr val="1E40AF"/>
+              <a:rPr sz="1200" b="0">
+                <a:solidFill>
+                  <a:srgbClr val="444444"/>
                 </a:solidFill>
               </a:rPr>
-              <a:t>▶ 회원가입 (하단 '회원가입' 클릭)</a:t>
-            </a:r>
-          </a:p>
-        </p:txBody>
-      </p:sp>
-      <p:sp>
-        <p:nvSpPr>
-          <p:cNvPr id="8" name="TextBox 7"/>
-          <p:cNvSpPr txBox="1"/>
-          <p:nvPr/>
-        </p:nvSpPr>
-        <p:spPr>
-          <a:xfrm>
-            <a:off x="5943600" y="1645920"/>
-            <a:ext cx="5486400" cy="1371600"/>
-          </a:xfrm>
-          <a:prstGeom prst="rect">
-            <a:avLst/>
-          </a:prstGeom>
-          <a:noFill/>
-        </p:spPr>
-        <p:txBody>
-          <a:bodyPr wrap="square">
-            <a:spAutoFit/>
-          </a:bodyPr>
-          <a:lstStyle/>
-          <a:p>
-            <a:pPr algn="l"/>
-            <a:r>
-              <a:rPr sz="1200" b="0">
-                <a:solidFill>
-                  <a:srgbClr val="666666"/>
-                </a:solidFill>
-              </a:rPr>
-              <a:t>• 이메일 + 비밀번호 기반 가입
-• 비밀번호 찾기 지원
-• 회원가입 후 바로 서비스 이용 가능</a:t>
+              <a:t>로그인 모달 하단 '회원가입' 링크 클릭 시
+회원가입 화면으로 전환됩니다.
+가입 방식:
+ - 이메일 + 비밀번호 입력
+ - 이용약관 동의
+ - 가입 완료 후 즉시 서비스 이용 가능
+테스트 계정:
+ - ID: test@motiveinnovation.co.kr
+ - PW: Test1234!@</a:t>
             </a:r>
           </a:p>
         </p:txBody>
@@ -4339,8 +4318,8 @@
         </p:nvSpPr>
         <p:spPr>
           <a:xfrm>
-            <a:off x="3200400" y="182880"/>
-            <a:ext cx="5790895" cy="594360"/>
+            <a:off x="3200400" y="137160"/>
+            <a:ext cx="5790895" cy="548640"/>
           </a:xfrm>
           <a:prstGeom prst="roundRect">
             <a:avLst/>
@@ -4372,7 +4351,7 @@
           <a:p>
             <a:pPr algn="ctr"/>
             <a:r>
-              <a:rPr sz="2400" b="1">
+              <a:rPr sz="2200" b="1">
                 <a:solidFill>
                   <a:srgbClr val="FFFFFF"/>
                 </a:solidFill>
@@ -4390,8 +4369,8 @@
         </p:nvSpPr>
         <p:spPr>
           <a:xfrm>
-            <a:off x="914400" y="914400"/>
-            <a:ext cx="10362895" cy="457200"/>
+            <a:off x="457200" y="777240"/>
+            <a:ext cx="11277295" cy="365760"/>
           </a:xfrm>
           <a:prstGeom prst="rect">
             <a:avLst/>
@@ -4406,12 +4385,12 @@
           <a:p>
             <a:pPr algn="ctr"/>
             <a:r>
-              <a:rPr sz="1400">
+              <a:rPr sz="1200">
                 <a:solidFill>
                   <a:srgbClr val="666666"/>
                 </a:solidFill>
               </a:rPr>
-              <a:t>모바일 앱 버전 로그인/회원가입 경로</a:t>
+              <a:t>www.owner-view.com 모바일 웹앱 로그인/회원가입 화면</a:t>
             </a:r>
           </a:p>
         </p:txBody>
@@ -4424,7 +4403,7 @@
         </p:nvSpPr>
         <p:spPr>
           <a:xfrm>
-            <a:off x="914400" y="1188720"/>
+            <a:off x="1371600" y="1097280"/>
             <a:ext cx="3657600" cy="274320"/>
           </a:xfrm>
           <a:prstGeom prst="rect">
@@ -4440,76 +4419,19 @@
           <a:p>
             <a:pPr algn="l"/>
             <a:r>
-              <a:rPr sz="1200" b="1">
+              <a:rPr sz="1300" b="1">
                 <a:solidFill>
                   <a:srgbClr val="1E40AF"/>
                 </a:solidFill>
               </a:rPr>
-              <a:t>▶ 로그인</a:t>
-            </a:r>
-          </a:p>
-        </p:txBody>
-      </p:sp>
-      <p:sp>
-        <p:nvSpPr>
-          <p:cNvPr id="5" name="Rounded Rectangle 4"/>
-          <p:cNvSpPr/>
-          <p:nvPr/>
-        </p:nvSpPr>
-        <p:spPr>
-          <a:xfrm>
-            <a:off x="914400" y="1463040"/>
-            <a:ext cx="3657600" cy="320040"/>
-          </a:xfrm>
-          <a:prstGeom prst="roundRect">
-            <a:avLst/>
-          </a:prstGeom>
-          <a:solidFill>
-            <a:srgbClr val="F1F3F5"/>
-          </a:solidFill>
-          <a:ln w="6350">
-            <a:solidFill>
-              <a:srgbClr val="DEDEDE"/>
-            </a:solidFill>
-          </a:ln>
-        </p:spPr>
-        <p:style>
-          <a:lnRef idx="1">
-            <a:schemeClr val="accent1"/>
-          </a:lnRef>
-          <a:fillRef idx="3">
-            <a:schemeClr val="accent1"/>
-          </a:fillRef>
-          <a:effectRef idx="2">
-            <a:schemeClr val="accent1"/>
-          </a:effectRef>
-          <a:fontRef idx="minor">
-            <a:schemeClr val="lt1"/>
-          </a:fontRef>
-        </p:style>
-        <p:txBody>
-          <a:bodyPr rtlCol="0" anchor="ctr" wrap="none"/>
-          <a:lstStyle/>
-          <a:p>
-            <a:pPr algn="l"/>
-            <a:r>
-              <a:rPr sz="1000"/>
-              <a:t>  🔒 </a:t>
-            </a:r>
-            <a:r>
-              <a:rPr sz="1000">
-                <a:solidFill>
-                  <a:srgbClr val="333333"/>
-                </a:solidFill>
-              </a:rPr>
-              <a:t>www.owner-view.com/auth</a:t>
+              <a:t>▶ 로그인 화면</a:t>
             </a:r>
           </a:p>
         </p:txBody>
       </p:sp>
       <p:pic>
         <p:nvPicPr>
-          <p:cNvPr id="6" name="Picture 5" descr="10-mobile-auth.png"/>
+          <p:cNvPr id="5" name="Picture 4" descr="09-mobile-login.png"/>
           <p:cNvPicPr>
             <a:picLocks noChangeAspect="1"/>
           </p:cNvPicPr>
@@ -4523,8 +4445,8 @@
         </p:blipFill>
         <p:spPr>
           <a:xfrm>
-            <a:off x="1371600" y="1783080"/>
-            <a:ext cx="2112654" cy="4572000"/>
+            <a:off x="1828800" y="1371600"/>
+            <a:ext cx="2084366" cy="5029200"/>
           </a:xfrm>
           <a:prstGeom prst="rect">
             <a:avLst/>
@@ -4533,13 +4455,13 @@
       </p:pic>
       <p:sp>
         <p:nvSpPr>
-          <p:cNvPr id="7" name="TextBox 6"/>
+          <p:cNvPr id="6" name="TextBox 5"/>
           <p:cNvSpPr txBox="1"/>
           <p:nvPr/>
         </p:nvSpPr>
         <p:spPr>
           <a:xfrm>
-            <a:off x="6400800" y="1188720"/>
+            <a:off x="6858000" y="1097280"/>
             <a:ext cx="4572000" cy="274320"/>
           </a:xfrm>
           <a:prstGeom prst="rect">
@@ -4555,76 +4477,19 @@
           <a:p>
             <a:pPr algn="l"/>
             <a:r>
-              <a:rPr sz="1200" b="1">
+              <a:rPr sz="1300" b="1">
                 <a:solidFill>
                   <a:srgbClr val="1E40AF"/>
                 </a:solidFill>
               </a:rPr>
-              <a:t>▶ 회원가입</a:t>
-            </a:r>
-          </a:p>
-        </p:txBody>
-      </p:sp>
-      <p:sp>
-        <p:nvSpPr>
-          <p:cNvPr id="8" name="Rounded Rectangle 7"/>
-          <p:cNvSpPr/>
-          <p:nvPr/>
-        </p:nvSpPr>
-        <p:spPr>
-          <a:xfrm>
-            <a:off x="6400800" y="1463040"/>
-            <a:ext cx="4572000" cy="320040"/>
-          </a:xfrm>
-          <a:prstGeom prst="roundRect">
-            <a:avLst/>
-          </a:prstGeom>
-          <a:solidFill>
-            <a:srgbClr val="F1F3F5"/>
-          </a:solidFill>
-          <a:ln w="6350">
-            <a:solidFill>
-              <a:srgbClr val="DEDEDE"/>
-            </a:solidFill>
-          </a:ln>
-        </p:spPr>
-        <p:style>
-          <a:lnRef idx="1">
-            <a:schemeClr val="accent1"/>
-          </a:lnRef>
-          <a:fillRef idx="3">
-            <a:schemeClr val="accent1"/>
-          </a:fillRef>
-          <a:effectRef idx="2">
-            <a:schemeClr val="accent1"/>
-          </a:effectRef>
-          <a:fontRef idx="minor">
-            <a:schemeClr val="lt1"/>
-          </a:fontRef>
-        </p:style>
-        <p:txBody>
-          <a:bodyPr rtlCol="0" anchor="ctr" wrap="none"/>
-          <a:lstStyle/>
-          <a:p>
-            <a:pPr algn="l"/>
-            <a:r>
-              <a:rPr sz="1000"/>
-              <a:t>  🔒 </a:t>
-            </a:r>
-            <a:r>
-              <a:rPr sz="1000">
-                <a:solidFill>
-                  <a:srgbClr val="333333"/>
-                </a:solidFill>
-              </a:rPr>
-              <a:t>www.owner-view.com/auth (회원가입 탭)</a:t>
+              <a:t>▶ 회원가입 화면</a:t>
             </a:r>
           </a:p>
         </p:txBody>
       </p:sp>
       <p:pic>
         <p:nvPicPr>
-          <p:cNvPr id="9" name="Picture 8" descr="11-mobile-signup.png"/>
+          <p:cNvPr id="7" name="Picture 6" descr="10-mobile-signup.png"/>
           <p:cNvPicPr>
             <a:picLocks noChangeAspect="1"/>
           </p:cNvPicPr>
@@ -4638,8 +4503,8 @@
         </p:blipFill>
         <p:spPr>
           <a:xfrm>
-            <a:off x="6858000" y="1783080"/>
-            <a:ext cx="2112654" cy="4572000"/>
+            <a:off x="7315200" y="1371600"/>
+            <a:ext cx="2084366" cy="5029200"/>
           </a:xfrm>
           <a:prstGeom prst="rect">
             <a:avLst/>
@@ -4680,8 +4545,8 @@
         </p:nvSpPr>
         <p:spPr>
           <a:xfrm>
-            <a:off x="3200400" y="182880"/>
-            <a:ext cx="5790895" cy="594360"/>
+            <a:off x="3200400" y="137160"/>
+            <a:ext cx="5790895" cy="548640"/>
           </a:xfrm>
           <a:prstGeom prst="roundRect">
             <a:avLst/>
@@ -4713,7 +4578,7 @@
           <a:p>
             <a:pPr algn="ctr"/>
             <a:r>
-              <a:rPr sz="2400" b="1">
+              <a:rPr sz="2200" b="1">
                 <a:solidFill>
                   <a:srgbClr val="FFFFFF"/>
                 </a:solidFill>
@@ -4731,8 +4596,8 @@
         </p:nvSpPr>
         <p:spPr>
           <a:xfrm>
-            <a:off x="914400" y="914400"/>
-            <a:ext cx="10362895" cy="457200"/>
+            <a:off x="457200" y="777240"/>
+            <a:ext cx="11277295" cy="365760"/>
           </a:xfrm>
           <a:prstGeom prst="rect">
             <a:avLst/>
@@ -4747,110 +4612,19 @@
           <a:p>
             <a:pPr algn="ctr"/>
             <a:r>
-              <a:rPr sz="1400">
+              <a:rPr sz="1200">
                 <a:solidFill>
                   <a:srgbClr val="666666"/>
                 </a:solidFill>
               </a:rPr>
-              <a:t>유/무형 상품의 구매 경로를 모두 캡처해주세요.</a:t>
-            </a:r>
-          </a:p>
-        </p:txBody>
-      </p:sp>
-      <p:sp>
-        <p:nvSpPr>
-          <p:cNvPr id="4" name="TextBox 3"/>
-          <p:cNvSpPr txBox="1"/>
-          <p:nvPr/>
-        </p:nvSpPr>
-        <p:spPr>
-          <a:xfrm>
-            <a:off x="457200" y="1188720"/>
-            <a:ext cx="10972800" cy="274320"/>
-          </a:xfrm>
-          <a:prstGeom prst="rect">
-            <a:avLst/>
-          </a:prstGeom>
-          <a:noFill/>
-        </p:spPr>
-        <p:txBody>
-          <a:bodyPr wrap="square">
-            <a:spAutoFit/>
-          </a:bodyPr>
-          <a:lstStyle/>
-          <a:p>
-            <a:pPr algn="l"/>
-            <a:r>
-              <a:rPr sz="1300" b="1">
-                <a:solidFill>
-                  <a:srgbClr val="1E40AF"/>
-                </a:solidFill>
-              </a:rPr>
-              <a:t>▶ STEP 1. 요금제 페이지에서 상품 확인</a:t>
-            </a:r>
-          </a:p>
-        </p:txBody>
-      </p:sp>
-      <p:sp>
-        <p:nvSpPr>
-          <p:cNvPr id="5" name="Rounded Rectangle 4"/>
-          <p:cNvSpPr/>
-          <p:nvPr/>
-        </p:nvSpPr>
-        <p:spPr>
-          <a:xfrm>
-            <a:off x="457200" y="1508760"/>
-            <a:ext cx="11277295" cy="320040"/>
-          </a:xfrm>
-          <a:prstGeom prst="roundRect">
-            <a:avLst/>
-          </a:prstGeom>
-          <a:solidFill>
-            <a:srgbClr val="F1F3F5"/>
-          </a:solidFill>
-          <a:ln w="6350">
-            <a:solidFill>
-              <a:srgbClr val="DEDEDE"/>
-            </a:solidFill>
-          </a:ln>
-        </p:spPr>
-        <p:style>
-          <a:lnRef idx="1">
-            <a:schemeClr val="accent1"/>
-          </a:lnRef>
-          <a:fillRef idx="3">
-            <a:schemeClr val="accent1"/>
-          </a:fillRef>
-          <a:effectRef idx="2">
-            <a:schemeClr val="accent1"/>
-          </a:effectRef>
-          <a:fontRef idx="minor">
-            <a:schemeClr val="lt1"/>
-          </a:fontRef>
-        </p:style>
-        <p:txBody>
-          <a:bodyPr rtlCol="0" anchor="ctr" wrap="none"/>
-          <a:lstStyle/>
-          <a:p>
-            <a:pPr algn="l"/>
-            <a:r>
-              <a:rPr sz="1000"/>
-              <a:t>  🔒 </a:t>
-            </a:r>
-            <a:r>
-              <a:rPr sz="1000">
-                <a:solidFill>
-                  <a:srgbClr val="333333"/>
-                </a:solidFill>
-              </a:rPr>
-              <a:t>motiveinno-jpg.github.io/motive-team/whistle-landing.html#pricing</a:t>
+              <a:t>STEP 1. 요금제 페이지에서 구독 플랜 확인 (Free / Starter / Pro)</a:t>
             </a:r>
           </a:p>
         </p:txBody>
       </p:sp>
       <p:pic>
         <p:nvPicPr>
-          <p:cNvPr id="6" name="Picture 5" descr="06-pricing.png"/>
+          <p:cNvPr id="4" name="Picture 3" descr="05-pricing.png"/>
           <p:cNvPicPr>
             <a:picLocks noChangeAspect="1"/>
           </p:cNvPicPr>
@@ -4864,8 +4638,8 @@
         </p:blipFill>
         <p:spPr>
           <a:xfrm>
-            <a:off x="457200" y="1828800"/>
-            <a:ext cx="11277295" cy="6343478"/>
+            <a:off x="457200" y="1234440"/>
+            <a:ext cx="11277295" cy="7198086"/>
           </a:xfrm>
           <a:prstGeom prst="rect">
             <a:avLst/>
@@ -4906,8 +4680,8 @@
         </p:nvSpPr>
         <p:spPr>
           <a:xfrm>
-            <a:off x="3200400" y="182880"/>
-            <a:ext cx="5790895" cy="594360"/>
+            <a:off x="3200400" y="137160"/>
+            <a:ext cx="5790895" cy="548640"/>
           </a:xfrm>
           <a:prstGeom prst="roundRect">
             <a:avLst/>
@@ -4939,7 +4713,7 @@
           <a:p>
             <a:pPr algn="ctr"/>
             <a:r>
-              <a:rPr sz="2400" b="1">
+              <a:rPr sz="2200" b="1">
                 <a:solidFill>
                   <a:srgbClr val="FFFFFF"/>
                 </a:solidFill>
@@ -4957,8 +4731,8 @@
         </p:nvSpPr>
         <p:spPr>
           <a:xfrm>
-            <a:off x="914400" y="914400"/>
-            <a:ext cx="10362895" cy="457200"/>
+            <a:off x="457200" y="777240"/>
+            <a:ext cx="11277295" cy="365760"/>
           </a:xfrm>
           <a:prstGeom prst="rect">
             <a:avLst/>
@@ -4973,110 +4747,19 @@
           <a:p>
             <a:pPr algn="ctr"/>
             <a:r>
-              <a:rPr sz="1400">
+              <a:rPr sz="1200">
                 <a:solidFill>
                   <a:srgbClr val="666666"/>
                 </a:solidFill>
               </a:rPr>
-              <a:t>구독 결제 버튼 + AI 수출 상품분석 보고서 단건결제(₩50,000)</a:t>
-            </a:r>
-          </a:p>
-        </p:txBody>
-      </p:sp>
-      <p:sp>
-        <p:nvSpPr>
-          <p:cNvPr id="4" name="TextBox 3"/>
-          <p:cNvSpPr txBox="1"/>
-          <p:nvPr/>
-        </p:nvSpPr>
-        <p:spPr>
-          <a:xfrm>
-            <a:off x="457200" y="1188720"/>
-            <a:ext cx="10972800" cy="274320"/>
-          </a:xfrm>
-          <a:prstGeom prst="rect">
-            <a:avLst/>
-          </a:prstGeom>
-          <a:noFill/>
-        </p:spPr>
-        <p:txBody>
-          <a:bodyPr wrap="square">
-            <a:spAutoFit/>
-          </a:bodyPr>
-          <a:lstStyle/>
-          <a:p>
-            <a:pPr algn="l"/>
-            <a:r>
-              <a:rPr sz="1300" b="1">
-                <a:solidFill>
-                  <a:srgbClr val="1E40AF"/>
-                </a:solidFill>
-              </a:rPr>
-              <a:t>▶ STEP 2. 구독 CTA 버튼 + 단건결제 상품</a:t>
-            </a:r>
-          </a:p>
-        </p:txBody>
-      </p:sp>
-      <p:sp>
-        <p:nvSpPr>
-          <p:cNvPr id="5" name="Rounded Rectangle 4"/>
-          <p:cNvSpPr/>
-          <p:nvPr/>
-        </p:nvSpPr>
-        <p:spPr>
-          <a:xfrm>
-            <a:off x="457200" y="1508760"/>
-            <a:ext cx="11277295" cy="320040"/>
-          </a:xfrm>
-          <a:prstGeom prst="roundRect">
-            <a:avLst/>
-          </a:prstGeom>
-          <a:solidFill>
-            <a:srgbClr val="F1F3F5"/>
-          </a:solidFill>
-          <a:ln w="6350">
-            <a:solidFill>
-              <a:srgbClr val="DEDEDE"/>
-            </a:solidFill>
-          </a:ln>
-        </p:spPr>
-        <p:style>
-          <a:lnRef idx="1">
-            <a:schemeClr val="accent1"/>
-          </a:lnRef>
-          <a:fillRef idx="3">
-            <a:schemeClr val="accent1"/>
-          </a:fillRef>
-          <a:effectRef idx="2">
-            <a:schemeClr val="accent1"/>
-          </a:effectRef>
-          <a:fontRef idx="minor">
-            <a:schemeClr val="lt1"/>
-          </a:fontRef>
-        </p:style>
-        <p:txBody>
-          <a:bodyPr rtlCol="0" anchor="ctr" wrap="none"/>
-          <a:lstStyle/>
-          <a:p>
-            <a:pPr algn="l"/>
-            <a:r>
-              <a:rPr sz="1000"/>
-              <a:t>  🔒 </a:t>
-            </a:r>
-            <a:r>
-              <a:rPr sz="1000">
-                <a:solidFill>
-                  <a:srgbClr val="333333"/>
-                </a:solidFill>
-              </a:rPr>
-              <a:t>motiveinno-jpg.github.io/motive-team/whistle-landing.html#pricing (스크롤)</a:t>
+              <a:t>STEP 2. 구독 CTA 버튼 + AI 수출 상품분석 보고서 단건결제 (₩50,000/건)</a:t>
             </a:r>
           </a:p>
         </p:txBody>
       </p:sp>
       <p:pic>
         <p:nvPicPr>
-          <p:cNvPr id="6" name="Picture 5" descr="07-pricing-buttons.png"/>
+          <p:cNvPr id="4" name="Picture 3" descr="06-pricing-cta.png"/>
           <p:cNvPicPr>
             <a:picLocks noChangeAspect="1"/>
           </p:cNvPicPr>
@@ -5090,82 +4773,14 @@
         </p:blipFill>
         <p:spPr>
           <a:xfrm>
-            <a:off x="457200" y="1828800"/>
-            <a:ext cx="11277295" cy="6343478"/>
+            <a:off x="457200" y="1234440"/>
+            <a:ext cx="11277295" cy="7198086"/>
           </a:xfrm>
           <a:prstGeom prst="rect">
             <a:avLst/>
           </a:prstGeom>
         </p:spPr>
       </p:pic>
-      <p:sp>
-        <p:nvSpPr>
-          <p:cNvPr id="7" name="TextBox 6"/>
-          <p:cNvSpPr txBox="1"/>
-          <p:nvPr/>
-        </p:nvSpPr>
-        <p:spPr>
-          <a:xfrm>
-            <a:off x="5486400" y="5303520"/>
-            <a:ext cx="5486400" cy="274320"/>
-          </a:xfrm>
-          <a:prstGeom prst="rect">
-            <a:avLst/>
-          </a:prstGeom>
-          <a:noFill/>
-        </p:spPr>
-        <p:txBody>
-          <a:bodyPr wrap="square">
-            <a:spAutoFit/>
-          </a:bodyPr>
-          <a:lstStyle/>
-          <a:p>
-            <a:pPr algn="l"/>
-            <a:r>
-              <a:rPr sz="1100" b="1">
-                <a:solidFill>
-                  <a:srgbClr val="EF4444"/>
-                </a:solidFill>
-              </a:rPr>
-              <a:t>← Starter 구독하기 (정기결제 ₩99,000/월)</a:t>
-            </a:r>
-          </a:p>
-        </p:txBody>
-      </p:sp>
-      <p:sp>
-        <p:nvSpPr>
-          <p:cNvPr id="8" name="TextBox 7"/>
-          <p:cNvSpPr txBox="1"/>
-          <p:nvPr/>
-        </p:nvSpPr>
-        <p:spPr>
-          <a:xfrm>
-            <a:off x="5486400" y="5669280"/>
-            <a:ext cx="5486400" cy="274320"/>
-          </a:xfrm>
-          <a:prstGeom prst="rect">
-            <a:avLst/>
-          </a:prstGeom>
-          <a:noFill/>
-        </p:spPr>
-        <p:txBody>
-          <a:bodyPr wrap="square">
-            <a:spAutoFit/>
-          </a:bodyPr>
-          <a:lstStyle/>
-          <a:p>
-            <a:pPr algn="l"/>
-            <a:r>
-              <a:rPr sz="1100" b="1">
-                <a:solidFill>
-                  <a:srgbClr val="F59E0B"/>
-                </a:solidFill>
-              </a:rPr>
-              <a:t>← AI 수출 상품분석 보고서 (단건결제 ₩50,000/건)</a:t>
-            </a:r>
-          </a:p>
-        </p:txBody>
-      </p:sp>
     </p:spTree>
   </p:cSld>
   <p:clrMapOvr>
@@ -5200,8 +4815,8 @@
         </p:nvSpPr>
         <p:spPr>
           <a:xfrm>
-            <a:off x="3200400" y="182880"/>
-            <a:ext cx="5790895" cy="594360"/>
+            <a:off x="3200400" y="137160"/>
+            <a:ext cx="5790895" cy="548640"/>
           </a:xfrm>
           <a:prstGeom prst="roundRect">
             <a:avLst/>
@@ -5233,7 +4848,7 @@
           <a:p>
             <a:pPr algn="ctr"/>
             <a:r>
-              <a:rPr sz="2400" b="1">
+              <a:rPr sz="2200" b="1">
                 <a:solidFill>
                   <a:srgbClr val="FFFFFF"/>
                 </a:solidFill>
@@ -5251,8 +4866,8 @@
         </p:nvSpPr>
         <p:spPr>
           <a:xfrm>
-            <a:off x="914400" y="914400"/>
-            <a:ext cx="10362895" cy="457200"/>
+            <a:off x="457200" y="777240"/>
+            <a:ext cx="11277295" cy="365760"/>
           </a:xfrm>
           <a:prstGeom prst="rect">
             <a:avLst/>
@@ -5267,12 +4882,12 @@
           <a:p>
             <a:pPr algn="ctr"/>
             <a:r>
-              <a:rPr sz="1400">
+              <a:rPr sz="1200">
                 <a:solidFill>
                   <a:srgbClr val="666666"/>
                 </a:solidFill>
               </a:rPr>
-              <a:t>결제 확인 모달 — 구독 결제(좌) / 단건결제(우)</a:t>
+              <a:t>STEP 3. 결제 확인 모달 — 구독 정기결제(좌) / AI 보고서 단건결제(우)</a:t>
             </a:r>
           </a:p>
         </p:txBody>
@@ -5285,7 +4900,7 @@
         </p:nvSpPr>
         <p:spPr>
           <a:xfrm>
-            <a:off x="274320" y="1188720"/>
+            <a:off x="274320" y="1097280"/>
             <a:ext cx="5486400" cy="274320"/>
           </a:xfrm>
           <a:prstGeom prst="rect">
@@ -5306,14 +4921,14 @@
                   <a:srgbClr val="1E40AF"/>
                 </a:solidFill>
               </a:rPr>
-              <a:t>▶ STEP 3-A. Starter 구독 결제 (₩99,000)</a:t>
+              <a:t>▶ Starter 구독 (₩99,000/월)</a:t>
             </a:r>
           </a:p>
         </p:txBody>
       </p:sp>
       <p:pic>
         <p:nvPicPr>
-          <p:cNvPr id="5" name="Picture 4" descr="08-checkout-modal.png"/>
+          <p:cNvPr id="5" name="Picture 4" descr="07-checkout-starter.png"/>
           <p:cNvPicPr>
             <a:picLocks noChangeAspect="1"/>
           </p:cNvPicPr>
@@ -5327,8 +4942,8 @@
         </p:blipFill>
         <p:spPr>
           <a:xfrm>
-            <a:off x="274320" y="1554480"/>
-            <a:ext cx="5669280" cy="3188970"/>
+            <a:off x="274320" y="1371600"/>
+            <a:ext cx="5669280" cy="3618595"/>
           </a:xfrm>
           <a:prstGeom prst="rect">
             <a:avLst/>
@@ -5343,7 +4958,7 @@
         </p:nvSpPr>
         <p:spPr>
           <a:xfrm>
-            <a:off x="6217920" y="1188720"/>
+            <a:off x="6217920" y="1097280"/>
             <a:ext cx="5486400" cy="274320"/>
           </a:xfrm>
           <a:prstGeom prst="rect">
@@ -5364,14 +4979,14 @@
                   <a:srgbClr val="1E40AF"/>
                 </a:solidFill>
               </a:rPr>
-              <a:t>▶ STEP 3-B. AI 보고서 단건결제 (₩50,000)</a:t>
+              <a:t>▶ AI 보고서 단건결제 (₩50,000)</a:t>
             </a:r>
           </a:p>
         </p:txBody>
       </p:sp>
       <p:pic>
         <p:nvPicPr>
-          <p:cNvPr id="7" name="Picture 6" descr="09-single-pay-modal.png"/>
+          <p:cNvPr id="7" name="Picture 6" descr="08-checkout-single.png"/>
           <p:cNvPicPr>
             <a:picLocks noChangeAspect="1"/>
           </p:cNvPicPr>
@@ -5385,8 +5000,8 @@
         </p:blipFill>
         <p:spPr>
           <a:xfrm>
-            <a:off x="6217920" y="1554480"/>
-            <a:ext cx="5669280" cy="3188970"/>
+            <a:off x="6217920" y="1371600"/>
+            <a:ext cx="5669280" cy="3618595"/>
           </a:xfrm>
           <a:prstGeom prst="rect">
             <a:avLst/>
@@ -5427,8 +5042,8 @@
         </p:nvSpPr>
         <p:spPr>
           <a:xfrm>
-            <a:off x="3200400" y="182880"/>
-            <a:ext cx="5790895" cy="594360"/>
+            <a:off x="3200400" y="137160"/>
+            <a:ext cx="5790895" cy="548640"/>
           </a:xfrm>
           <a:prstGeom prst="roundRect">
             <a:avLst/>
@@ -5460,7 +5075,7 @@
           <a:p>
             <a:pPr algn="ctr"/>
             <a:r>
-              <a:rPr sz="2400" b="1">
+              <a:rPr sz="2200" b="1">
                 <a:solidFill>
                   <a:srgbClr val="FFFFFF"/>
                 </a:solidFill>
@@ -5478,8 +5093,8 @@
         </p:nvSpPr>
         <p:spPr>
           <a:xfrm>
-            <a:off x="914400" y="914400"/>
-            <a:ext cx="10362895" cy="457200"/>
+            <a:off x="457200" y="777240"/>
+            <a:ext cx="11277295" cy="365760"/>
           </a:xfrm>
           <a:prstGeom prst="rect">
             <a:avLst/>
@@ -5494,61 +5109,40 @@
           <a:p>
             <a:pPr algn="ctr"/>
             <a:r>
-              <a:rPr sz="1400">
+              <a:rPr sz="1200">
                 <a:solidFill>
                   <a:srgbClr val="666666"/>
                 </a:solidFill>
               </a:rPr>
-              <a:t>토스페이먼츠 SDK v2 표준 결제창을 통해 카드 결제가 진행됩니다.</a:t>
-            </a:r>
-          </a:p>
-        </p:txBody>
-      </p:sp>
-      <p:sp>
-        <p:nvSpPr>
-          <p:cNvPr id="4" name="Rounded Rectangle 3"/>
-          <p:cNvSpPr/>
+              <a:t>토스페이먼츠 SDK v2 표준 결제창 — 카드사 선택 화면 (테스트 모드)</a:t>
+            </a:r>
+          </a:p>
+        </p:txBody>
+      </p:sp>
+      <p:pic>
+        <p:nvPicPr>
+          <p:cNvPr id="4" name="Picture 3" descr="11-toss-payment.png"/>
+          <p:cNvPicPr>
+            <a:picLocks noChangeAspect="1"/>
+          </p:cNvPicPr>
           <p:nvPr/>
-        </p:nvSpPr>
-        <p:spPr>
-          <a:xfrm>
-            <a:off x="1828800" y="1645920"/>
-            <a:ext cx="8534095" cy="4114800"/>
-          </a:xfrm>
-          <a:prstGeom prst="roundRect">
-            <a:avLst/>
-          </a:prstGeom>
-          <a:solidFill>
-            <a:srgbClr val="F0F4FF"/>
-          </a:solidFill>
-          <a:ln>
-            <a:solidFill>
-              <a:srgbClr val="BFDBFE"/>
-            </a:solidFill>
-          </a:ln>
-        </p:spPr>
-        <p:style>
-          <a:lnRef idx="1">
-            <a:schemeClr val="accent1"/>
-          </a:lnRef>
-          <a:fillRef idx="3">
-            <a:schemeClr val="accent1"/>
-          </a:fillRef>
-          <a:effectRef idx="2">
-            <a:schemeClr val="accent1"/>
-          </a:effectRef>
-          <a:fontRef idx="minor">
-            <a:schemeClr val="lt1"/>
-          </a:fontRef>
-        </p:style>
-        <p:txBody>
-          <a:bodyPr rtlCol="0" anchor="ctr"/>
-          <a:lstStyle/>
-          <a:p>
-            <a:pPr algn="ctr"/>
-          </a:p>
-        </p:txBody>
-      </p:sp>
+        </p:nvPicPr>
+        <p:blipFill>
+          <a:blip r:embed="rId2"/>
+          <a:stretch>
+            <a:fillRect/>
+          </a:stretch>
+        </p:blipFill>
+        <p:spPr>
+          <a:xfrm>
+            <a:off x="1371600" y="1234440"/>
+            <a:ext cx="9448495" cy="6030797"/>
+          </a:xfrm>
+          <a:prstGeom prst="rect">
+            <a:avLst/>
+          </a:prstGeom>
+        </p:spPr>
+      </p:pic>
       <p:sp>
         <p:nvSpPr>
           <p:cNvPr id="5" name="TextBox 4"/>
@@ -5557,8 +5151,8 @@
         </p:nvSpPr>
         <p:spPr>
           <a:xfrm>
-            <a:off x="2286000" y="2011680"/>
-            <a:ext cx="7619695" cy="457200"/>
+            <a:off x="1371600" y="6400800"/>
+            <a:ext cx="9448495" cy="320040"/>
           </a:xfrm>
           <a:prstGeom prst="rect">
             <a:avLst/>
@@ -5573,124 +5167,12 @@
           <a:p>
             <a:pPr algn="ctr"/>
             <a:r>
-              <a:rPr sz="2200" b="1">
-                <a:solidFill>
-                  <a:srgbClr val="000000"/>
+              <a:rPr sz="1100" b="0">
+                <a:solidFill>
+                  <a:srgbClr val="666666"/>
                 </a:solidFill>
               </a:rPr>
-              <a:t>토스페이먼츠 표준 결제창 (SDK v2)</a:t>
-            </a:r>
-          </a:p>
-        </p:txBody>
-      </p:sp>
-      <p:sp>
-        <p:nvSpPr>
-          <p:cNvPr id="6" name="TextBox 5"/>
-          <p:cNvSpPr txBox="1"/>
-          <p:nvPr/>
-        </p:nvSpPr>
-        <p:spPr>
-          <a:xfrm>
-            <a:off x="2743200" y="2743200"/>
-            <a:ext cx="6705295" cy="2743200"/>
-          </a:xfrm>
-          <a:prstGeom prst="rect">
-            <a:avLst/>
-          </a:prstGeom>
-          <a:noFill/>
-        </p:spPr>
-        <p:txBody>
-          <a:bodyPr wrap="square">
-            <a:spAutoFit/>
-          </a:bodyPr>
-          <a:lstStyle/>
-          <a:p>
-            <a:pPr algn="l"/>
-            <a:r>
-              <a:rPr sz="1400" b="0">
-                <a:solidFill>
-                  <a:srgbClr val="333333"/>
-                </a:solidFill>
-              </a:rPr>
-              <a:t>결제 흐름:
-1. 사용자가 "결제하기" 버튼 클릭
-2. TossPayments SDK 로드 → requestPayment() 호출
-3. 토스페이먼츠 표준 결제 팝업 표시
-   • 결제 방법: 신용카드 / 체크카드
-   • 카드사 선택 → 카드번호 입력 → 결제 인증
-4. 결제 성공 시 → successUrl로 리다이렉트
-5. 결제 실패 시 → failUrl로 리다이렉트
-※ 테스트용 결제창 연동 가이드: https://docs.tosspayments.com/preview/1
-※ 가맹점 승인 후 실 결제 테스트 및 캡처 가능</a:t>
-            </a:r>
-          </a:p>
-        </p:txBody>
-      </p:sp>
-      <p:sp>
-        <p:nvSpPr>
-          <p:cNvPr id="7" name="TextBox 6"/>
-          <p:cNvSpPr txBox="1"/>
-          <p:nvPr/>
-        </p:nvSpPr>
-        <p:spPr>
-          <a:xfrm>
-            <a:off x="2286000" y="5303520"/>
-            <a:ext cx="7315200" cy="274320"/>
-          </a:xfrm>
-          <a:prstGeom prst="rect">
-            <a:avLst/>
-          </a:prstGeom>
-          <a:noFill/>
-        </p:spPr>
-        <p:txBody>
-          <a:bodyPr wrap="square">
-            <a:spAutoFit/>
-          </a:bodyPr>
-          <a:lstStyle/>
-          <a:p>
-            <a:pPr algn="l"/>
-            <a:r>
-              <a:rPr sz="1100" b="1">
-                <a:solidFill>
-                  <a:srgbClr val="1E40AF"/>
-                </a:solidFill>
-              </a:rPr>
-              <a:t>연동 코드 (SDK v2):</a:t>
-            </a:r>
-          </a:p>
-        </p:txBody>
-      </p:sp>
-      <p:sp>
-        <p:nvSpPr>
-          <p:cNvPr id="8" name="TextBox 7"/>
-          <p:cNvSpPr txBox="1"/>
-          <p:nvPr/>
-        </p:nvSpPr>
-        <p:spPr>
-          <a:xfrm>
-            <a:off x="2286000" y="5577840"/>
-            <a:ext cx="7315200" cy="731520"/>
-          </a:xfrm>
-          <a:prstGeom prst="rect">
-            <a:avLst/>
-          </a:prstGeom>
-          <a:noFill/>
-        </p:spPr>
-        <p:txBody>
-          <a:bodyPr wrap="square">
-            <a:spAutoFit/>
-          </a:bodyPr>
-          <a:lstStyle/>
-          <a:p>
-            <a:pPr algn="l"/>
-            <a:r>
-              <a:rPr sz="1000" b="0">
-                <a:solidFill>
-                  <a:srgbClr val="555555"/>
-                </a:solidFill>
-              </a:rPr>
-              <a:t>const toss = TossPayments("클라이언트키");
-toss.payment({customerKey}).requestPayment({method:"CARD", amount:{value:99000, currency:"KRW"}, ...})</a:t>
+              <a:t>※ 토스페이먼츠 테스트 결제창 (실제 결제 안됨) — 가맹점 승인 후 실 결제 연동 예정</a:t>
             </a:r>
           </a:p>
         </p:txBody>

</xml_diff>